<commit_message>
loaded RFR model, applied anti-log to the sleep efficiency output
</commit_message>
<xml_diff>
--- a/Project Files/Presentations/Group_8Implementation_new.pptx
+++ b/Project Files/Presentations/Group_8Implementation_new.pptx
@@ -5,10 +5,10 @@
     <p:sldMasterId id="2147483705" r:id="rId4"/>
   </p:sldMasterIdLst>
   <p:notesMasterIdLst>
-    <p:notesMasterId r:id="rId33"/>
+    <p:notesMasterId r:id="rId27"/>
   </p:notesMasterIdLst>
   <p:handoutMasterIdLst>
-    <p:handoutMasterId r:id="rId34"/>
+    <p:handoutMasterId r:id="rId28"/>
   </p:handoutMasterIdLst>
   <p:sldIdLst>
     <p:sldId id="278" r:id="rId5"/>
@@ -29,16 +29,10 @@
     <p:sldId id="297" r:id="rId20"/>
     <p:sldId id="285" r:id="rId21"/>
     <p:sldId id="303" r:id="rId22"/>
-    <p:sldId id="304" r:id="rId23"/>
-    <p:sldId id="298" r:id="rId24"/>
-    <p:sldId id="299" r:id="rId25"/>
-    <p:sldId id="300" r:id="rId26"/>
-    <p:sldId id="301" r:id="rId27"/>
-    <p:sldId id="302" r:id="rId28"/>
-    <p:sldId id="305" r:id="rId29"/>
-    <p:sldId id="306" r:id="rId30"/>
-    <p:sldId id="307" r:id="rId31"/>
-    <p:sldId id="308" r:id="rId32"/>
+    <p:sldId id="319" r:id="rId23"/>
+    <p:sldId id="320" r:id="rId24"/>
+    <p:sldId id="321" r:id="rId25"/>
+    <p:sldId id="322" r:id="rId26"/>
   </p:sldIdLst>
   <p:sldSz cx="12192000" cy="6858000"/>
   <p:notesSz cx="6858000" cy="9144000"/>
@@ -164,16 +158,10 @@
             <p14:sldId id="297"/>
             <p14:sldId id="285"/>
             <p14:sldId id="303"/>
-            <p14:sldId id="304"/>
-            <p14:sldId id="298"/>
-            <p14:sldId id="299"/>
-            <p14:sldId id="300"/>
-            <p14:sldId id="301"/>
-            <p14:sldId id="302"/>
-            <p14:sldId id="305"/>
-            <p14:sldId id="306"/>
-            <p14:sldId id="307"/>
-            <p14:sldId id="308"/>
+            <p14:sldId id="319"/>
+            <p14:sldId id="320"/>
+            <p14:sldId id="321"/>
+            <p14:sldId id="322"/>
           </p14:sldIdLst>
         </p14:section>
       </p14:sectionLst>
@@ -293,7 +281,7 @@
           <a:p>
             <a:fld id="{717BC71B-6527-4638-937B-C93EB849CB02}" type="datetimeFigureOut">
               <a:rPr lang="en-US" smtClean="0"/>
-              <a:t>3/22/2025</a:t>
+              <a:t>3/24/2025</a:t>
             </a:fld>
             <a:endParaRPr lang="en-US" dirty="0"/>
           </a:p>
@@ -470,7 +458,7 @@
           <a:p>
             <a:fld id="{425465A2-8C9C-419F-9FD8-234480873777}" type="datetimeFigureOut">
               <a:rPr lang="en-US" smtClean="0"/>
-              <a:t>3/22/2025</a:t>
+              <a:t>3/24/2025</a:t>
             </a:fld>
             <a:endParaRPr lang="en-US" dirty="0"/>
           </a:p>
@@ -1651,7 +1639,7 @@
     </p:spTree>
     <p:extLst>
       <p:ext uri="{BB962C8B-B14F-4D97-AF65-F5344CB8AC3E}">
-        <p14:creationId xmlns:p14="http://schemas.microsoft.com/office/powerpoint/2010/main" val="3178922684"/>
+        <p14:creationId xmlns:p14="http://schemas.microsoft.com/office/powerpoint/2010/main" val="1369252900"/>
       </p:ext>
     </p:extLst>
   </p:cSld>
@@ -1819,7 +1807,7 @@
     </p:spTree>
     <p:extLst>
       <p:ext uri="{BB962C8B-B14F-4D97-AF65-F5344CB8AC3E}">
-        <p14:creationId xmlns:p14="http://schemas.microsoft.com/office/powerpoint/2010/main" val="1826349582"/>
+        <p14:creationId xmlns:p14="http://schemas.microsoft.com/office/powerpoint/2010/main" val="3530784417"/>
       </p:ext>
     </p:extLst>
   </p:cSld>
@@ -1903,7 +1891,7 @@
     </p:spTree>
     <p:extLst>
       <p:ext uri="{BB962C8B-B14F-4D97-AF65-F5344CB8AC3E}">
-        <p14:creationId xmlns:p14="http://schemas.microsoft.com/office/powerpoint/2010/main" val="1621199814"/>
+        <p14:creationId xmlns:p14="http://schemas.microsoft.com/office/powerpoint/2010/main" val="556645673"/>
       </p:ext>
     </p:extLst>
   </p:cSld>
@@ -1987,511 +1975,7 @@
     </p:spTree>
     <p:extLst>
       <p:ext uri="{BB962C8B-B14F-4D97-AF65-F5344CB8AC3E}">
-        <p14:creationId xmlns:p14="http://schemas.microsoft.com/office/powerpoint/2010/main" val="209733023"/>
-      </p:ext>
-    </p:extLst>
-  </p:cSld>
-  <p:clrMapOvr>
-    <a:masterClrMapping/>
-  </p:clrMapOvr>
-</p:notes>
-</file>
-
-<file path=ppt/notesSlides/notesSlide23.xml><?xml version="1.0" encoding="utf-8"?>
-<p:notes xmlns:a="http://schemas.openxmlformats.org/drawingml/2006/main" xmlns:r="http://schemas.openxmlformats.org/officeDocument/2006/relationships" xmlns:p="http://schemas.openxmlformats.org/presentationml/2006/main">
-  <p:cSld>
-    <p:spTree>
-      <p:nvGrpSpPr>
-        <p:cNvPr id="1" name=""/>
-        <p:cNvGrpSpPr/>
-        <p:nvPr/>
-      </p:nvGrpSpPr>
-      <p:grpSpPr>
-        <a:xfrm>
-          <a:off x="0" y="0"/>
-          <a:ext cx="0" cy="0"/>
-          <a:chOff x="0" y="0"/>
-          <a:chExt cx="0" cy="0"/>
-        </a:xfrm>
-      </p:grpSpPr>
-      <p:sp>
-        <p:nvSpPr>
-          <p:cNvPr id="2" name="Slide Image Placeholder 1"/>
-          <p:cNvSpPr>
-            <a:spLocks noGrp="1" noRot="1" noChangeAspect="1"/>
-          </p:cNvSpPr>
-          <p:nvPr>
-            <p:ph type="sldImg"/>
-          </p:nvPr>
-        </p:nvSpPr>
-        <p:spPr/>
-      </p:sp>
-      <p:sp>
-        <p:nvSpPr>
-          <p:cNvPr id="3" name="Notes Placeholder 2"/>
-          <p:cNvSpPr>
-            <a:spLocks noGrp="1"/>
-          </p:cNvSpPr>
-          <p:nvPr>
-            <p:ph type="body" idx="1"/>
-          </p:nvPr>
-        </p:nvSpPr>
-        <p:spPr/>
-        <p:txBody>
-          <a:bodyPr/>
-          <a:lstStyle/>
-          <a:p>
-            <a:endParaRPr lang="en-US" dirty="0"/>
-          </a:p>
-        </p:txBody>
-      </p:sp>
-      <p:sp>
-        <p:nvSpPr>
-          <p:cNvPr id="4" name="Slide Number Placeholder 3"/>
-          <p:cNvSpPr>
-            <a:spLocks noGrp="1"/>
-          </p:cNvSpPr>
-          <p:nvPr>
-            <p:ph type="sldNum" sz="quarter" idx="5"/>
-          </p:nvPr>
-        </p:nvSpPr>
-        <p:spPr/>
-        <p:txBody>
-          <a:bodyPr/>
-          <a:lstStyle/>
-          <a:p>
-            <a:fld id="{E7AF00E9-A49D-4007-B3B9-A3783809E505}" type="slidenum">
-              <a:rPr lang="en-US" smtClean="0"/>
-              <a:t>23</a:t>
-            </a:fld>
-            <a:endParaRPr lang="en-US" dirty="0"/>
-          </a:p>
-        </p:txBody>
-      </p:sp>
-    </p:spTree>
-    <p:extLst>
-      <p:ext uri="{BB962C8B-B14F-4D97-AF65-F5344CB8AC3E}">
-        <p14:creationId xmlns:p14="http://schemas.microsoft.com/office/powerpoint/2010/main" val="3359593813"/>
-      </p:ext>
-    </p:extLst>
-  </p:cSld>
-  <p:clrMapOvr>
-    <a:masterClrMapping/>
-  </p:clrMapOvr>
-</p:notes>
-</file>
-
-<file path=ppt/notesSlides/notesSlide24.xml><?xml version="1.0" encoding="utf-8"?>
-<p:notes xmlns:a="http://schemas.openxmlformats.org/drawingml/2006/main" xmlns:r="http://schemas.openxmlformats.org/officeDocument/2006/relationships" xmlns:p="http://schemas.openxmlformats.org/presentationml/2006/main">
-  <p:cSld>
-    <p:spTree>
-      <p:nvGrpSpPr>
-        <p:cNvPr id="1" name=""/>
-        <p:cNvGrpSpPr/>
-        <p:nvPr/>
-      </p:nvGrpSpPr>
-      <p:grpSpPr>
-        <a:xfrm>
-          <a:off x="0" y="0"/>
-          <a:ext cx="0" cy="0"/>
-          <a:chOff x="0" y="0"/>
-          <a:chExt cx="0" cy="0"/>
-        </a:xfrm>
-      </p:grpSpPr>
-      <p:sp>
-        <p:nvSpPr>
-          <p:cNvPr id="2" name="Slide Image Placeholder 1"/>
-          <p:cNvSpPr>
-            <a:spLocks noGrp="1" noRot="1" noChangeAspect="1"/>
-          </p:cNvSpPr>
-          <p:nvPr>
-            <p:ph type="sldImg"/>
-          </p:nvPr>
-        </p:nvSpPr>
-        <p:spPr/>
-      </p:sp>
-      <p:sp>
-        <p:nvSpPr>
-          <p:cNvPr id="3" name="Notes Placeholder 2"/>
-          <p:cNvSpPr>
-            <a:spLocks noGrp="1"/>
-          </p:cNvSpPr>
-          <p:nvPr>
-            <p:ph type="body" idx="1"/>
-          </p:nvPr>
-        </p:nvSpPr>
-        <p:spPr/>
-        <p:txBody>
-          <a:bodyPr/>
-          <a:lstStyle/>
-          <a:p>
-            <a:endParaRPr lang="en-US" dirty="0"/>
-          </a:p>
-        </p:txBody>
-      </p:sp>
-      <p:sp>
-        <p:nvSpPr>
-          <p:cNvPr id="4" name="Slide Number Placeholder 3"/>
-          <p:cNvSpPr>
-            <a:spLocks noGrp="1"/>
-          </p:cNvSpPr>
-          <p:nvPr>
-            <p:ph type="sldNum" sz="quarter" idx="5"/>
-          </p:nvPr>
-        </p:nvSpPr>
-        <p:spPr/>
-        <p:txBody>
-          <a:bodyPr/>
-          <a:lstStyle/>
-          <a:p>
-            <a:fld id="{E7AF00E9-A49D-4007-B3B9-A3783809E505}" type="slidenum">
-              <a:rPr lang="en-US" smtClean="0"/>
-              <a:t>24</a:t>
-            </a:fld>
-            <a:endParaRPr lang="en-US" dirty="0"/>
-          </a:p>
-        </p:txBody>
-      </p:sp>
-    </p:spTree>
-    <p:extLst>
-      <p:ext uri="{BB962C8B-B14F-4D97-AF65-F5344CB8AC3E}">
-        <p14:creationId xmlns:p14="http://schemas.microsoft.com/office/powerpoint/2010/main" val="3401854040"/>
-      </p:ext>
-    </p:extLst>
-  </p:cSld>
-  <p:clrMapOvr>
-    <a:masterClrMapping/>
-  </p:clrMapOvr>
-</p:notes>
-</file>
-
-<file path=ppt/notesSlides/notesSlide25.xml><?xml version="1.0" encoding="utf-8"?>
-<p:notes xmlns:a="http://schemas.openxmlformats.org/drawingml/2006/main" xmlns:r="http://schemas.openxmlformats.org/officeDocument/2006/relationships" xmlns:p="http://schemas.openxmlformats.org/presentationml/2006/main">
-  <p:cSld>
-    <p:spTree>
-      <p:nvGrpSpPr>
-        <p:cNvPr id="1" name=""/>
-        <p:cNvGrpSpPr/>
-        <p:nvPr/>
-      </p:nvGrpSpPr>
-      <p:grpSpPr>
-        <a:xfrm>
-          <a:off x="0" y="0"/>
-          <a:ext cx="0" cy="0"/>
-          <a:chOff x="0" y="0"/>
-          <a:chExt cx="0" cy="0"/>
-        </a:xfrm>
-      </p:grpSpPr>
-      <p:sp>
-        <p:nvSpPr>
-          <p:cNvPr id="2" name="Slide Image Placeholder 1"/>
-          <p:cNvSpPr>
-            <a:spLocks noGrp="1" noRot="1" noChangeAspect="1"/>
-          </p:cNvSpPr>
-          <p:nvPr>
-            <p:ph type="sldImg"/>
-          </p:nvPr>
-        </p:nvSpPr>
-        <p:spPr/>
-      </p:sp>
-      <p:sp>
-        <p:nvSpPr>
-          <p:cNvPr id="3" name="Notes Placeholder 2"/>
-          <p:cNvSpPr>
-            <a:spLocks noGrp="1"/>
-          </p:cNvSpPr>
-          <p:nvPr>
-            <p:ph type="body" idx="1"/>
-          </p:nvPr>
-        </p:nvSpPr>
-        <p:spPr/>
-        <p:txBody>
-          <a:bodyPr/>
-          <a:lstStyle/>
-          <a:p>
-            <a:endParaRPr lang="en-US" dirty="0"/>
-          </a:p>
-        </p:txBody>
-      </p:sp>
-      <p:sp>
-        <p:nvSpPr>
-          <p:cNvPr id="4" name="Slide Number Placeholder 3"/>
-          <p:cNvSpPr>
-            <a:spLocks noGrp="1"/>
-          </p:cNvSpPr>
-          <p:nvPr>
-            <p:ph type="sldNum" sz="quarter" idx="5"/>
-          </p:nvPr>
-        </p:nvSpPr>
-        <p:spPr/>
-        <p:txBody>
-          <a:bodyPr/>
-          <a:lstStyle/>
-          <a:p>
-            <a:fld id="{E7AF00E9-A49D-4007-B3B9-A3783809E505}" type="slidenum">
-              <a:rPr lang="en-US" smtClean="0"/>
-              <a:t>25</a:t>
-            </a:fld>
-            <a:endParaRPr lang="en-US" dirty="0"/>
-          </a:p>
-        </p:txBody>
-      </p:sp>
-    </p:spTree>
-    <p:extLst>
-      <p:ext uri="{BB962C8B-B14F-4D97-AF65-F5344CB8AC3E}">
-        <p14:creationId xmlns:p14="http://schemas.microsoft.com/office/powerpoint/2010/main" val="2728449379"/>
-      </p:ext>
-    </p:extLst>
-  </p:cSld>
-  <p:clrMapOvr>
-    <a:masterClrMapping/>
-  </p:clrMapOvr>
-</p:notes>
-</file>
-
-<file path=ppt/notesSlides/notesSlide26.xml><?xml version="1.0" encoding="utf-8"?>
-<p:notes xmlns:a="http://schemas.openxmlformats.org/drawingml/2006/main" xmlns:r="http://schemas.openxmlformats.org/officeDocument/2006/relationships" xmlns:p="http://schemas.openxmlformats.org/presentationml/2006/main">
-  <p:cSld>
-    <p:spTree>
-      <p:nvGrpSpPr>
-        <p:cNvPr id="1" name=""/>
-        <p:cNvGrpSpPr/>
-        <p:nvPr/>
-      </p:nvGrpSpPr>
-      <p:grpSpPr>
-        <a:xfrm>
-          <a:off x="0" y="0"/>
-          <a:ext cx="0" cy="0"/>
-          <a:chOff x="0" y="0"/>
-          <a:chExt cx="0" cy="0"/>
-        </a:xfrm>
-      </p:grpSpPr>
-      <p:sp>
-        <p:nvSpPr>
-          <p:cNvPr id="2" name="Slide Image Placeholder 1"/>
-          <p:cNvSpPr>
-            <a:spLocks noGrp="1" noRot="1" noChangeAspect="1"/>
-          </p:cNvSpPr>
-          <p:nvPr>
-            <p:ph type="sldImg"/>
-          </p:nvPr>
-        </p:nvSpPr>
-        <p:spPr/>
-      </p:sp>
-      <p:sp>
-        <p:nvSpPr>
-          <p:cNvPr id="3" name="Notes Placeholder 2"/>
-          <p:cNvSpPr>
-            <a:spLocks noGrp="1"/>
-          </p:cNvSpPr>
-          <p:nvPr>
-            <p:ph type="body" idx="1"/>
-          </p:nvPr>
-        </p:nvSpPr>
-        <p:spPr/>
-        <p:txBody>
-          <a:bodyPr/>
-          <a:lstStyle/>
-          <a:p>
-            <a:endParaRPr lang="en-US" dirty="0"/>
-          </a:p>
-        </p:txBody>
-      </p:sp>
-      <p:sp>
-        <p:nvSpPr>
-          <p:cNvPr id="4" name="Slide Number Placeholder 3"/>
-          <p:cNvSpPr>
-            <a:spLocks noGrp="1"/>
-          </p:cNvSpPr>
-          <p:nvPr>
-            <p:ph type="sldNum" sz="quarter" idx="5"/>
-          </p:nvPr>
-        </p:nvSpPr>
-        <p:spPr/>
-        <p:txBody>
-          <a:bodyPr/>
-          <a:lstStyle/>
-          <a:p>
-            <a:fld id="{E7AF00E9-A49D-4007-B3B9-A3783809E505}" type="slidenum">
-              <a:rPr lang="en-US" smtClean="0"/>
-              <a:t>26</a:t>
-            </a:fld>
-            <a:endParaRPr lang="en-US" dirty="0"/>
-          </a:p>
-        </p:txBody>
-      </p:sp>
-    </p:spTree>
-    <p:extLst>
-      <p:ext uri="{BB962C8B-B14F-4D97-AF65-F5344CB8AC3E}">
-        <p14:creationId xmlns:p14="http://schemas.microsoft.com/office/powerpoint/2010/main" val="1898812337"/>
-      </p:ext>
-    </p:extLst>
-  </p:cSld>
-  <p:clrMapOvr>
-    <a:masterClrMapping/>
-  </p:clrMapOvr>
-</p:notes>
-</file>
-
-<file path=ppt/notesSlides/notesSlide27.xml><?xml version="1.0" encoding="utf-8"?>
-<p:notes xmlns:a="http://schemas.openxmlformats.org/drawingml/2006/main" xmlns:r="http://schemas.openxmlformats.org/officeDocument/2006/relationships" xmlns:p="http://schemas.openxmlformats.org/presentationml/2006/main">
-  <p:cSld>
-    <p:spTree>
-      <p:nvGrpSpPr>
-        <p:cNvPr id="1" name=""/>
-        <p:cNvGrpSpPr/>
-        <p:nvPr/>
-      </p:nvGrpSpPr>
-      <p:grpSpPr>
-        <a:xfrm>
-          <a:off x="0" y="0"/>
-          <a:ext cx="0" cy="0"/>
-          <a:chOff x="0" y="0"/>
-          <a:chExt cx="0" cy="0"/>
-        </a:xfrm>
-      </p:grpSpPr>
-      <p:sp>
-        <p:nvSpPr>
-          <p:cNvPr id="2" name="Slide Image Placeholder 1"/>
-          <p:cNvSpPr>
-            <a:spLocks noGrp="1" noRot="1" noChangeAspect="1"/>
-          </p:cNvSpPr>
-          <p:nvPr>
-            <p:ph type="sldImg"/>
-          </p:nvPr>
-        </p:nvSpPr>
-        <p:spPr/>
-      </p:sp>
-      <p:sp>
-        <p:nvSpPr>
-          <p:cNvPr id="3" name="Notes Placeholder 2"/>
-          <p:cNvSpPr>
-            <a:spLocks noGrp="1"/>
-          </p:cNvSpPr>
-          <p:nvPr>
-            <p:ph type="body" idx="1"/>
-          </p:nvPr>
-        </p:nvSpPr>
-        <p:spPr/>
-        <p:txBody>
-          <a:bodyPr/>
-          <a:lstStyle/>
-          <a:p>
-            <a:endParaRPr lang="en-US" dirty="0"/>
-          </a:p>
-        </p:txBody>
-      </p:sp>
-      <p:sp>
-        <p:nvSpPr>
-          <p:cNvPr id="4" name="Slide Number Placeholder 3"/>
-          <p:cNvSpPr>
-            <a:spLocks noGrp="1"/>
-          </p:cNvSpPr>
-          <p:nvPr>
-            <p:ph type="sldNum" sz="quarter" idx="5"/>
-          </p:nvPr>
-        </p:nvSpPr>
-        <p:spPr/>
-        <p:txBody>
-          <a:bodyPr/>
-          <a:lstStyle/>
-          <a:p>
-            <a:fld id="{E7AF00E9-A49D-4007-B3B9-A3783809E505}" type="slidenum">
-              <a:rPr lang="en-US" smtClean="0"/>
-              <a:t>27</a:t>
-            </a:fld>
-            <a:endParaRPr lang="en-US" dirty="0"/>
-          </a:p>
-        </p:txBody>
-      </p:sp>
-    </p:spTree>
-    <p:extLst>
-      <p:ext uri="{BB962C8B-B14F-4D97-AF65-F5344CB8AC3E}">
-        <p14:creationId xmlns:p14="http://schemas.microsoft.com/office/powerpoint/2010/main" val="1476101825"/>
-      </p:ext>
-    </p:extLst>
-  </p:cSld>
-  <p:clrMapOvr>
-    <a:masterClrMapping/>
-  </p:clrMapOvr>
-</p:notes>
-</file>
-
-<file path=ppt/notesSlides/notesSlide28.xml><?xml version="1.0" encoding="utf-8"?>
-<p:notes xmlns:a="http://schemas.openxmlformats.org/drawingml/2006/main" xmlns:r="http://schemas.openxmlformats.org/officeDocument/2006/relationships" xmlns:p="http://schemas.openxmlformats.org/presentationml/2006/main">
-  <p:cSld>
-    <p:spTree>
-      <p:nvGrpSpPr>
-        <p:cNvPr id="1" name=""/>
-        <p:cNvGrpSpPr/>
-        <p:nvPr/>
-      </p:nvGrpSpPr>
-      <p:grpSpPr>
-        <a:xfrm>
-          <a:off x="0" y="0"/>
-          <a:ext cx="0" cy="0"/>
-          <a:chOff x="0" y="0"/>
-          <a:chExt cx="0" cy="0"/>
-        </a:xfrm>
-      </p:grpSpPr>
-      <p:sp>
-        <p:nvSpPr>
-          <p:cNvPr id="2" name="Slide Image Placeholder 1"/>
-          <p:cNvSpPr>
-            <a:spLocks noGrp="1" noRot="1" noChangeAspect="1"/>
-          </p:cNvSpPr>
-          <p:nvPr>
-            <p:ph type="sldImg"/>
-          </p:nvPr>
-        </p:nvSpPr>
-        <p:spPr/>
-      </p:sp>
-      <p:sp>
-        <p:nvSpPr>
-          <p:cNvPr id="3" name="Notes Placeholder 2"/>
-          <p:cNvSpPr>
-            <a:spLocks noGrp="1"/>
-          </p:cNvSpPr>
-          <p:nvPr>
-            <p:ph type="body" idx="1"/>
-          </p:nvPr>
-        </p:nvSpPr>
-        <p:spPr/>
-        <p:txBody>
-          <a:bodyPr/>
-          <a:lstStyle/>
-          <a:p>
-            <a:endParaRPr lang="en-US" dirty="0"/>
-          </a:p>
-        </p:txBody>
-      </p:sp>
-      <p:sp>
-        <p:nvSpPr>
-          <p:cNvPr id="4" name="Slide Number Placeholder 3"/>
-          <p:cNvSpPr>
-            <a:spLocks noGrp="1"/>
-          </p:cNvSpPr>
-          <p:nvPr>
-            <p:ph type="sldNum" sz="quarter" idx="5"/>
-          </p:nvPr>
-        </p:nvSpPr>
-        <p:spPr/>
-        <p:txBody>
-          <a:bodyPr/>
-          <a:lstStyle/>
-          <a:p>
-            <a:fld id="{E7AF00E9-A49D-4007-B3B9-A3783809E505}" type="slidenum">
-              <a:rPr lang="en-US" smtClean="0"/>
-              <a:t>28</a:t>
-            </a:fld>
-            <a:endParaRPr lang="en-US" dirty="0"/>
-          </a:p>
-        </p:txBody>
-      </p:sp>
-    </p:spTree>
-    <p:extLst>
-      <p:ext uri="{BB962C8B-B14F-4D97-AF65-F5344CB8AC3E}">
-        <p14:creationId xmlns:p14="http://schemas.microsoft.com/office/powerpoint/2010/main" val="1350639701"/>
+        <p14:creationId xmlns:p14="http://schemas.microsoft.com/office/powerpoint/2010/main" val="1028659096"/>
       </p:ext>
     </p:extLst>
   </p:cSld>
@@ -4790,7 +4274,7 @@
                 <a16:creationId xmlns:a16="http://schemas.microsoft.com/office/drawing/2014/main" id="{57BF9F63-86BE-5515-AD3C-59481B3FF4B4}"/>
               </a:ext>
               <a:ext uri="{C183D7F6-B498-43B3-948B-1728B52AA6E4}">
-                <adec:decorative xmlns:adec="http://schemas.microsoft.com/office/drawing/2017/decorative" xmlns="" val="1"/>
+                <adec:decorative xmlns="" xmlns:adec="http://schemas.microsoft.com/office/drawing/2017/decorative" val="1"/>
               </a:ext>
             </a:extLst>
           </p:cNvPr>
@@ -5111,7 +4595,7 @@
                 <a16:creationId xmlns:a16="http://schemas.microsoft.com/office/drawing/2014/main" id="{60ABD6E1-FE78-D78B-E80C-09490F5D8D05}"/>
               </a:ext>
               <a:ext uri="{C183D7F6-B498-43B3-948B-1728B52AA6E4}">
-                <adec:decorative xmlns:adec="http://schemas.microsoft.com/office/drawing/2017/decorative" xmlns="" val="1"/>
+                <adec:decorative xmlns="" xmlns:adec="http://schemas.microsoft.com/office/drawing/2017/decorative" val="1"/>
               </a:ext>
             </a:extLst>
           </p:cNvPr>
@@ -5199,7 +4683,7 @@
                 <a16:creationId xmlns:a16="http://schemas.microsoft.com/office/drawing/2014/main" id="{62BB1BCD-5C1C-ED05-D6B4-F92367209BEF}"/>
               </a:ext>
               <a:ext uri="{C183D7F6-B498-43B3-948B-1728B52AA6E4}">
-                <adec:decorative xmlns:adec="http://schemas.microsoft.com/office/drawing/2017/decorative" xmlns="" val="1"/>
+                <adec:decorative xmlns="" xmlns:adec="http://schemas.microsoft.com/office/drawing/2017/decorative" val="1"/>
               </a:ext>
             </a:extLst>
           </p:cNvPr>
@@ -13607,13 +13091,7 @@
               <a:rPr lang="en-US" dirty="0" smtClean="0">
                 <a:latin typeface="+mn-lt"/>
               </a:rPr>
-              <a:t>Preparing Pipeline: </a:t>
-            </a:r>
-            <a:r>
-              <a:rPr lang="en-US" dirty="0" smtClean="0">
-                <a:latin typeface="+mn-lt"/>
-              </a:rPr>
-              <a:t>Sleep Analysis Model (Overview)</a:t>
+              <a:t>Preparing Pipeline: Sleep Analysis Model (Overview)</a:t>
             </a:r>
             <a:endParaRPr lang="en-US" dirty="0">
               <a:latin typeface="+mn-lt"/>
@@ -13715,19 +13193,7 @@
               <a:rPr lang="en-US" dirty="0" smtClean="0">
                 <a:latin typeface="+mn-lt"/>
               </a:rPr>
-              <a:t>Splitting and training</a:t>
-            </a:r>
-            <a:r>
-              <a:rPr lang="en-US" dirty="0" smtClean="0">
-                <a:latin typeface="+mn-lt"/>
-              </a:rPr>
-              <a:t>: </a:t>
-            </a:r>
-            <a:r>
-              <a:rPr lang="en-US" dirty="0" smtClean="0">
-                <a:latin typeface="+mn-lt"/>
-              </a:rPr>
-              <a:t>Sleep Analysis Model (Overview)</a:t>
+              <a:t>Splitting and training: Sleep Analysis Model (Overview)</a:t>
             </a:r>
             <a:endParaRPr lang="en-US" dirty="0">
               <a:latin typeface="+mn-lt"/>
@@ -13875,19 +13341,7 @@
               <a:rPr lang="en-US" dirty="0" smtClean="0">
                 <a:latin typeface="+mn-lt"/>
               </a:rPr>
-              <a:t>Splitting and training</a:t>
-            </a:r>
-            <a:r>
-              <a:rPr lang="en-US" dirty="0" smtClean="0">
-                <a:latin typeface="+mn-lt"/>
-              </a:rPr>
-              <a:t>: </a:t>
-            </a:r>
-            <a:r>
-              <a:rPr lang="en-US" dirty="0" smtClean="0">
-                <a:latin typeface="+mn-lt"/>
-              </a:rPr>
-              <a:t>Sleep Analysis Model (Overview)</a:t>
+              <a:t>Splitting and training: Sleep Analysis Model (Overview)</a:t>
             </a:r>
             <a:endParaRPr lang="en-US" dirty="0">
               <a:latin typeface="+mn-lt"/>
@@ -14031,13 +13485,7 @@
               <a:rPr lang="en-US" dirty="0" smtClean="0">
                 <a:latin typeface="+mn-lt"/>
               </a:rPr>
-              <a:t>: </a:t>
-            </a:r>
-            <a:r>
-              <a:rPr lang="en-US" dirty="0" smtClean="0">
-                <a:latin typeface="+mn-lt"/>
-              </a:rPr>
-              <a:t>Sleep Analysis Model (Overview)</a:t>
+              <a:t>: Sleep Analysis Model (Overview)</a:t>
             </a:r>
             <a:endParaRPr lang="en-US" dirty="0">
               <a:latin typeface="+mn-lt"/>
@@ -14199,7 +13647,19 @@
               <a:rPr lang="en-US" dirty="0" smtClean="0">
                 <a:latin typeface="+mn-lt"/>
               </a:rPr>
-              <a:t>UI Design using PyQt5</a:t>
+              <a:t>UI Design </a:t>
+            </a:r>
+            <a:r>
+              <a:rPr lang="en-US" dirty="0" smtClean="0">
+                <a:latin typeface="+mn-lt"/>
+              </a:rPr>
+              <a:t>using React + </a:t>
+            </a:r>
+            <a:r>
+              <a:rPr lang="en-US" dirty="0" err="1" smtClean="0">
+                <a:latin typeface="+mn-lt"/>
+              </a:rPr>
+              <a:t>Vite</a:t>
             </a:r>
             <a:endParaRPr lang="en-US" dirty="0">
               <a:latin typeface="+mn-lt"/>
@@ -14277,7 +13737,31 @@
               <a:rPr lang="en-US" dirty="0" smtClean="0">
                 <a:latin typeface="+mn-lt"/>
               </a:rPr>
-              <a:t>Code: UI Design by PyQt5 (Overview)</a:t>
+              <a:t>Code: UI Design by </a:t>
+            </a:r>
+            <a:r>
+              <a:rPr lang="en-US" dirty="0" smtClean="0">
+                <a:latin typeface="+mn-lt"/>
+              </a:rPr>
+              <a:t>React + </a:t>
+            </a:r>
+            <a:r>
+              <a:rPr lang="en-US" dirty="0" err="1" smtClean="0">
+                <a:latin typeface="+mn-lt"/>
+              </a:rPr>
+              <a:t>Vite</a:t>
+            </a:r>
+            <a:r>
+              <a:rPr lang="en-US" dirty="0" smtClean="0">
+                <a:latin typeface="+mn-lt"/>
+              </a:rPr>
+              <a:t> </a:t>
+            </a:r>
+            <a:r>
+              <a:rPr lang="en-US" dirty="0" smtClean="0">
+                <a:latin typeface="+mn-lt"/>
+              </a:rPr>
+              <a:t>(Overview)</a:t>
             </a:r>
             <a:endParaRPr lang="en-US" dirty="0">
               <a:latin typeface="+mn-lt"/>
@@ -14287,46 +13771,28 @@
       </p:sp>
       <p:pic>
         <p:nvPicPr>
-          <p:cNvPr id="6" name="Picture 5"/>
+          <p:cNvPr id="3" name="Picture 2"/>
           <p:cNvPicPr>
             <a:picLocks noChangeAspect="1"/>
           </p:cNvPicPr>
           <p:nvPr/>
         </p:nvPicPr>
         <p:blipFill>
-          <a:blip r:embed="rId3"/>
+          <a:blip r:embed="rId3">
+            <a:extLst>
+              <a:ext uri="{28A0092B-C50C-407E-A947-70E740481C1C}">
+                <a14:useLocalDpi xmlns:a14="http://schemas.microsoft.com/office/drawing/2010/main" val="0"/>
+              </a:ext>
+            </a:extLst>
+          </a:blip>
           <a:stretch>
             <a:fillRect/>
           </a:stretch>
         </p:blipFill>
         <p:spPr>
           <a:xfrm>
-            <a:off x="798568" y="1933303"/>
-            <a:ext cx="10562249" cy="4800872"/>
-          </a:xfrm>
-          <a:prstGeom prst="rect">
-            <a:avLst/>
-          </a:prstGeom>
-        </p:spPr>
-      </p:pic>
-      <p:pic>
-        <p:nvPicPr>
-          <p:cNvPr id="7" name="Picture 6"/>
-          <p:cNvPicPr>
-            <a:picLocks noChangeAspect="1"/>
-          </p:cNvPicPr>
-          <p:nvPr/>
-        </p:nvPicPr>
-        <p:blipFill>
-          <a:blip r:embed="rId4"/>
-          <a:stretch>
-            <a:fillRect/>
-          </a:stretch>
-        </p:blipFill>
-        <p:spPr>
-          <a:xfrm>
-            <a:off x="3428277" y="1140824"/>
-            <a:ext cx="4772422" cy="600892"/>
+            <a:off x="0" y="923730"/>
+            <a:ext cx="12192000" cy="5934270"/>
           </a:xfrm>
           <a:prstGeom prst="rect">
             <a:avLst/>
@@ -14403,7 +13869,31 @@
               <a:rPr lang="en-US" dirty="0" smtClean="0">
                 <a:latin typeface="+mn-lt"/>
               </a:rPr>
-              <a:t>Code: UI Design by PyQt5 (Overview)</a:t>
+              <a:t>Code: UI Design by </a:t>
+            </a:r>
+            <a:r>
+              <a:rPr lang="en-US" dirty="0" smtClean="0">
+                <a:latin typeface="+mn-lt"/>
+              </a:rPr>
+              <a:t>React + </a:t>
+            </a:r>
+            <a:r>
+              <a:rPr lang="en-US" dirty="0" err="1" smtClean="0">
+                <a:latin typeface="+mn-lt"/>
+              </a:rPr>
+              <a:t>Vite</a:t>
+            </a:r>
+            <a:r>
+              <a:rPr lang="en-US" dirty="0" smtClean="0">
+                <a:latin typeface="+mn-lt"/>
+              </a:rPr>
+              <a:t> </a:t>
+            </a:r>
+            <a:r>
+              <a:rPr lang="en-US" dirty="0" smtClean="0">
+                <a:latin typeface="+mn-lt"/>
+              </a:rPr>
+              <a:t>(Overview)</a:t>
             </a:r>
             <a:endParaRPr lang="en-US" dirty="0">
               <a:latin typeface="+mn-lt"/>
@@ -14413,22 +13903,28 @@
       </p:sp>
       <p:pic>
         <p:nvPicPr>
-          <p:cNvPr id="3" name="Picture 2"/>
+          <p:cNvPr id="4" name="Picture 3"/>
           <p:cNvPicPr>
             <a:picLocks noChangeAspect="1"/>
           </p:cNvPicPr>
           <p:nvPr/>
         </p:nvPicPr>
         <p:blipFill>
-          <a:blip r:embed="rId3"/>
+          <a:blip r:embed="rId3">
+            <a:extLst>
+              <a:ext uri="{28A0092B-C50C-407E-A947-70E740481C1C}">
+                <a14:useLocalDpi xmlns:a14="http://schemas.microsoft.com/office/drawing/2010/main" val="0"/>
+              </a:ext>
+            </a:extLst>
+          </a:blip>
           <a:stretch>
             <a:fillRect/>
           </a:stretch>
         </p:blipFill>
         <p:spPr>
           <a:xfrm>
-            <a:off x="0" y="870857"/>
-            <a:ext cx="12204575" cy="5863772"/>
+            <a:off x="0" y="801188"/>
+            <a:ext cx="12192000" cy="6056812"/>
           </a:xfrm>
           <a:prstGeom prst="rect">
             <a:avLst/>
@@ -14438,7 +13934,7 @@
     </p:spTree>
     <p:extLst>
       <p:ext uri="{BB962C8B-B14F-4D97-AF65-F5344CB8AC3E}">
-        <p14:creationId xmlns:p14="http://schemas.microsoft.com/office/powerpoint/2010/main" val="3517652420"/>
+        <p14:creationId xmlns:p14="http://schemas.microsoft.com/office/powerpoint/2010/main" val="272144561"/>
       </p:ext>
     </p:extLst>
   </p:cSld>
@@ -14606,7 +14102,31 @@
               <a:rPr lang="en-US" dirty="0" smtClean="0">
                 <a:latin typeface="+mn-lt"/>
               </a:rPr>
-              <a:t>Code: UI Design by PyQt5 (Overview)</a:t>
+              <a:t>Code: UI Design by </a:t>
+            </a:r>
+            <a:r>
+              <a:rPr lang="en-US" dirty="0" smtClean="0">
+                <a:latin typeface="+mn-lt"/>
+              </a:rPr>
+              <a:t>React + </a:t>
+            </a:r>
+            <a:r>
+              <a:rPr lang="en-US" dirty="0" err="1" smtClean="0">
+                <a:latin typeface="+mn-lt"/>
+              </a:rPr>
+              <a:t>Vite</a:t>
+            </a:r>
+            <a:r>
+              <a:rPr lang="en-US" dirty="0" smtClean="0">
+                <a:latin typeface="+mn-lt"/>
+              </a:rPr>
+              <a:t> </a:t>
+            </a:r>
+            <a:r>
+              <a:rPr lang="en-US" dirty="0" smtClean="0">
+                <a:latin typeface="+mn-lt"/>
+              </a:rPr>
+              <a:t>(Overview)</a:t>
             </a:r>
             <a:endParaRPr lang="en-US" dirty="0">
               <a:latin typeface="+mn-lt"/>
@@ -14616,22 +14136,28 @@
       </p:sp>
       <p:pic>
         <p:nvPicPr>
-          <p:cNvPr id="5" name="Picture 4"/>
+          <p:cNvPr id="3" name="Picture 2"/>
           <p:cNvPicPr>
             <a:picLocks noChangeAspect="1"/>
           </p:cNvPicPr>
           <p:nvPr/>
         </p:nvPicPr>
         <p:blipFill>
-          <a:blip r:embed="rId3"/>
+          <a:blip r:embed="rId3">
+            <a:extLst>
+              <a:ext uri="{28A0092B-C50C-407E-A947-70E740481C1C}">
+                <a14:useLocalDpi xmlns:a14="http://schemas.microsoft.com/office/drawing/2010/main" val="0"/>
+              </a:ext>
+            </a:extLst>
+          </a:blip>
           <a:stretch>
             <a:fillRect/>
           </a:stretch>
         </p:blipFill>
         <p:spPr>
           <a:xfrm>
-            <a:off x="2450840" y="2717075"/>
-            <a:ext cx="6790930" cy="1566125"/>
+            <a:off x="1873180" y="801189"/>
+            <a:ext cx="7937203" cy="5962262"/>
           </a:xfrm>
           <a:prstGeom prst="rect">
             <a:avLst/>
@@ -14641,7 +14167,7 @@
     </p:spTree>
     <p:extLst>
       <p:ext uri="{BB962C8B-B14F-4D97-AF65-F5344CB8AC3E}">
-        <p14:creationId xmlns:p14="http://schemas.microsoft.com/office/powerpoint/2010/main" val="2175367618"/>
+        <p14:creationId xmlns:p14="http://schemas.microsoft.com/office/powerpoint/2010/main" val="3303027124"/>
       </p:ext>
     </p:extLst>
   </p:cSld>
@@ -14708,7 +14234,31 @@
               <a:rPr lang="en-US" dirty="0" smtClean="0">
                 <a:latin typeface="+mn-lt"/>
               </a:rPr>
-              <a:t>Code: UI Design by PyQt5 (Overview)</a:t>
+              <a:t>Code: UI Design by </a:t>
+            </a:r>
+            <a:r>
+              <a:rPr lang="en-US" dirty="0" smtClean="0">
+                <a:latin typeface="+mn-lt"/>
+              </a:rPr>
+              <a:t>React + </a:t>
+            </a:r>
+            <a:r>
+              <a:rPr lang="en-US" dirty="0" err="1" smtClean="0">
+                <a:latin typeface="+mn-lt"/>
+              </a:rPr>
+              <a:t>Vite</a:t>
+            </a:r>
+            <a:r>
+              <a:rPr lang="en-US" dirty="0" smtClean="0">
+                <a:latin typeface="+mn-lt"/>
+              </a:rPr>
+              <a:t> </a:t>
+            </a:r>
+            <a:r>
+              <a:rPr lang="en-US" dirty="0" smtClean="0">
+                <a:latin typeface="+mn-lt"/>
+              </a:rPr>
+              <a:t>(Overview)</a:t>
             </a:r>
             <a:endParaRPr lang="en-US" dirty="0">
               <a:latin typeface="+mn-lt"/>
@@ -14718,22 +14268,28 @@
       </p:sp>
       <p:pic>
         <p:nvPicPr>
-          <p:cNvPr id="3" name="Picture 2"/>
+          <p:cNvPr id="4" name="Picture 3"/>
           <p:cNvPicPr>
             <a:picLocks noChangeAspect="1"/>
           </p:cNvPicPr>
           <p:nvPr/>
         </p:nvPicPr>
         <p:blipFill>
-          <a:blip r:embed="rId3"/>
+          <a:blip r:embed="rId3">
+            <a:extLst>
+              <a:ext uri="{28A0092B-C50C-407E-A947-70E740481C1C}">
+                <a14:useLocalDpi xmlns:a14="http://schemas.microsoft.com/office/drawing/2010/main" val="0"/>
+              </a:ext>
+            </a:extLst>
+          </a:blip>
           <a:stretch>
             <a:fillRect/>
           </a:stretch>
         </p:blipFill>
         <p:spPr>
           <a:xfrm>
-            <a:off x="2873829" y="1418944"/>
-            <a:ext cx="6043748" cy="4637203"/>
+            <a:off x="0" y="886408"/>
+            <a:ext cx="12192000" cy="5971592"/>
           </a:xfrm>
           <a:prstGeom prst="rect">
             <a:avLst/>
@@ -14743,7 +14299,7 @@
     </p:spTree>
     <p:extLst>
       <p:ext uri="{BB962C8B-B14F-4D97-AF65-F5344CB8AC3E}">
-        <p14:creationId xmlns:p14="http://schemas.microsoft.com/office/powerpoint/2010/main" val="2533843445"/>
+        <p14:creationId xmlns:p14="http://schemas.microsoft.com/office/powerpoint/2010/main" val="3568159677"/>
       </p:ext>
     </p:extLst>
   </p:cSld>
@@ -14810,7 +14366,31 @@
               <a:rPr lang="en-US" dirty="0" smtClean="0">
                 <a:latin typeface="+mn-lt"/>
               </a:rPr>
-              <a:t>Code: UI Design by PyQt5 (Overview)</a:t>
+              <a:t>Code: UI Design by </a:t>
+            </a:r>
+            <a:r>
+              <a:rPr lang="en-US" dirty="0" smtClean="0">
+                <a:latin typeface="+mn-lt"/>
+              </a:rPr>
+              <a:t>React + </a:t>
+            </a:r>
+            <a:r>
+              <a:rPr lang="en-US" dirty="0" err="1" smtClean="0">
+                <a:latin typeface="+mn-lt"/>
+              </a:rPr>
+              <a:t>Vite</a:t>
+            </a:r>
+            <a:r>
+              <a:rPr lang="en-US" dirty="0" smtClean="0">
+                <a:latin typeface="+mn-lt"/>
+              </a:rPr>
+              <a:t> </a:t>
+            </a:r>
+            <a:r>
+              <a:rPr lang="en-US" dirty="0" smtClean="0">
+                <a:latin typeface="+mn-lt"/>
+              </a:rPr>
+              <a:t>(Overview)</a:t>
             </a:r>
             <a:endParaRPr lang="en-US" dirty="0">
               <a:latin typeface="+mn-lt"/>
@@ -14820,22 +14400,28 @@
       </p:sp>
       <p:pic>
         <p:nvPicPr>
-          <p:cNvPr id="4" name="Picture 3"/>
+          <p:cNvPr id="3" name="Picture 2"/>
           <p:cNvPicPr>
             <a:picLocks noChangeAspect="1"/>
           </p:cNvPicPr>
           <p:nvPr/>
         </p:nvPicPr>
         <p:blipFill>
-          <a:blip r:embed="rId3"/>
+          <a:blip r:embed="rId3">
+            <a:extLst>
+              <a:ext uri="{28A0092B-C50C-407E-A947-70E740481C1C}">
+                <a14:useLocalDpi xmlns:a14="http://schemas.microsoft.com/office/drawing/2010/main" val="0"/>
+              </a:ext>
+            </a:extLst>
+          </a:blip>
           <a:stretch>
             <a:fillRect/>
           </a:stretch>
         </p:blipFill>
         <p:spPr>
           <a:xfrm>
-            <a:off x="3492138" y="1491209"/>
-            <a:ext cx="5590902" cy="4697749"/>
+            <a:off x="0" y="886408"/>
+            <a:ext cx="12192000" cy="5971592"/>
           </a:xfrm>
           <a:prstGeom prst="rect">
             <a:avLst/>
@@ -14845,703 +14431,7 @@
     </p:spTree>
     <p:extLst>
       <p:ext uri="{BB962C8B-B14F-4D97-AF65-F5344CB8AC3E}">
-        <p14:creationId xmlns:p14="http://schemas.microsoft.com/office/powerpoint/2010/main" val="1527450490"/>
-      </p:ext>
-    </p:extLst>
-  </p:cSld>
-  <p:clrMapOvr>
-    <a:masterClrMapping/>
-  </p:clrMapOvr>
-  <p:timing>
-    <p:tnLst>
-      <p:par>
-        <p:cTn id="1" dur="indefinite" restart="never" nodeType="tmRoot"/>
-      </p:par>
-    </p:tnLst>
-  </p:timing>
-</p:sld>
-</file>
-
-<file path=ppt/slides/slide23.xml><?xml version="1.0" encoding="utf-8"?>
-<p:sld xmlns:a="http://schemas.openxmlformats.org/drawingml/2006/main" xmlns:r="http://schemas.openxmlformats.org/officeDocument/2006/relationships" xmlns:p="http://schemas.openxmlformats.org/presentationml/2006/main">
-  <p:cSld>
-    <p:spTree>
-      <p:nvGrpSpPr>
-        <p:cNvPr id="1" name=""/>
-        <p:cNvGrpSpPr/>
-        <p:nvPr/>
-      </p:nvGrpSpPr>
-      <p:grpSpPr>
-        <a:xfrm>
-          <a:off x="0" y="0"/>
-          <a:ext cx="0" cy="0"/>
-          <a:chOff x="0" y="0"/>
-          <a:chExt cx="0" cy="0"/>
-        </a:xfrm>
-      </p:grpSpPr>
-      <p:sp>
-        <p:nvSpPr>
-          <p:cNvPr id="2" name="Title 1">
-            <a:extLst>
-              <a:ext uri="{FF2B5EF4-FFF2-40B4-BE49-F238E27FC236}">
-                <a16:creationId xmlns:a16="http://schemas.microsoft.com/office/drawing/2014/main" id="{954ABE40-AA00-F366-A36A-B3F1AADBF025}"/>
-              </a:ext>
-            </a:extLst>
-          </p:cNvPr>
-          <p:cNvSpPr>
-            <a:spLocks noGrp="1"/>
-          </p:cNvSpPr>
-          <p:nvPr>
-            <p:ph type="ctrTitle"/>
-          </p:nvPr>
-        </p:nvSpPr>
-        <p:spPr>
-          <a:xfrm>
-            <a:off x="550862" y="196900"/>
-            <a:ext cx="11057663" cy="604289"/>
-          </a:xfrm>
-          <a:noFill/>
-        </p:spPr>
-        <p:txBody>
-          <a:bodyPr>
-            <a:noAutofit/>
-          </a:bodyPr>
-          <a:lstStyle/>
-          <a:p>
-            <a:r>
-              <a:rPr lang="en-US" dirty="0" smtClean="0">
-                <a:latin typeface="+mn-lt"/>
-              </a:rPr>
-              <a:t>Code: UI Design by PyQt5 (Overview)</a:t>
-            </a:r>
-            <a:endParaRPr lang="en-US" dirty="0">
-              <a:latin typeface="+mn-lt"/>
-            </a:endParaRPr>
-          </a:p>
-        </p:txBody>
-      </p:sp>
-      <p:pic>
-        <p:nvPicPr>
-          <p:cNvPr id="3" name="Picture 2"/>
-          <p:cNvPicPr>
-            <a:picLocks noChangeAspect="1"/>
-          </p:cNvPicPr>
-          <p:nvPr/>
-        </p:nvPicPr>
-        <p:blipFill>
-          <a:blip r:embed="rId3"/>
-          <a:stretch>
-            <a:fillRect/>
-          </a:stretch>
-        </p:blipFill>
-        <p:spPr>
-          <a:xfrm>
-            <a:off x="482437" y="2038156"/>
-            <a:ext cx="11159624" cy="3657250"/>
-          </a:xfrm>
-          <a:prstGeom prst="rect">
-            <a:avLst/>
-          </a:prstGeom>
-        </p:spPr>
-      </p:pic>
-    </p:spTree>
-    <p:extLst>
-      <p:ext uri="{BB962C8B-B14F-4D97-AF65-F5344CB8AC3E}">
-        <p14:creationId xmlns:p14="http://schemas.microsoft.com/office/powerpoint/2010/main" val="2848722883"/>
-      </p:ext>
-    </p:extLst>
-  </p:cSld>
-  <p:clrMapOvr>
-    <a:masterClrMapping/>
-  </p:clrMapOvr>
-  <p:timing>
-    <p:tnLst>
-      <p:par>
-        <p:cTn id="1" dur="indefinite" restart="never" nodeType="tmRoot"/>
-      </p:par>
-    </p:tnLst>
-  </p:timing>
-</p:sld>
-</file>
-
-<file path=ppt/slides/slide24.xml><?xml version="1.0" encoding="utf-8"?>
-<p:sld xmlns:a="http://schemas.openxmlformats.org/drawingml/2006/main" xmlns:r="http://schemas.openxmlformats.org/officeDocument/2006/relationships" xmlns:p="http://schemas.openxmlformats.org/presentationml/2006/main">
-  <p:cSld>
-    <p:spTree>
-      <p:nvGrpSpPr>
-        <p:cNvPr id="1" name=""/>
-        <p:cNvGrpSpPr/>
-        <p:nvPr/>
-      </p:nvGrpSpPr>
-      <p:grpSpPr>
-        <a:xfrm>
-          <a:off x="0" y="0"/>
-          <a:ext cx="0" cy="0"/>
-          <a:chOff x="0" y="0"/>
-          <a:chExt cx="0" cy="0"/>
-        </a:xfrm>
-      </p:grpSpPr>
-      <p:sp>
-        <p:nvSpPr>
-          <p:cNvPr id="2" name="Title 1">
-            <a:extLst>
-              <a:ext uri="{FF2B5EF4-FFF2-40B4-BE49-F238E27FC236}">
-                <a16:creationId xmlns:a16="http://schemas.microsoft.com/office/drawing/2014/main" id="{954ABE40-AA00-F366-A36A-B3F1AADBF025}"/>
-              </a:ext>
-            </a:extLst>
-          </p:cNvPr>
-          <p:cNvSpPr>
-            <a:spLocks noGrp="1"/>
-          </p:cNvSpPr>
-          <p:nvPr>
-            <p:ph type="ctrTitle"/>
-          </p:nvPr>
-        </p:nvSpPr>
-        <p:spPr>
-          <a:xfrm>
-            <a:off x="550862" y="196900"/>
-            <a:ext cx="11057663" cy="604289"/>
-          </a:xfrm>
-          <a:noFill/>
-        </p:spPr>
-        <p:txBody>
-          <a:bodyPr>
-            <a:noAutofit/>
-          </a:bodyPr>
-          <a:lstStyle/>
-          <a:p>
-            <a:r>
-              <a:rPr lang="en-US" dirty="0" smtClean="0">
-                <a:latin typeface="+mn-lt"/>
-              </a:rPr>
-              <a:t>Code: UI Design by PyQt5 (Overview)</a:t>
-            </a:r>
-            <a:endParaRPr lang="en-US" dirty="0">
-              <a:latin typeface="+mn-lt"/>
-            </a:endParaRPr>
-          </a:p>
-        </p:txBody>
-      </p:sp>
-      <p:pic>
-        <p:nvPicPr>
-          <p:cNvPr id="4" name="Picture 3"/>
-          <p:cNvPicPr>
-            <a:picLocks noChangeAspect="1"/>
-          </p:cNvPicPr>
-          <p:nvPr/>
-        </p:nvPicPr>
-        <p:blipFill>
-          <a:blip r:embed="rId3"/>
-          <a:stretch>
-            <a:fillRect/>
-          </a:stretch>
-        </p:blipFill>
-        <p:spPr>
-          <a:xfrm>
-            <a:off x="3793656" y="2034969"/>
-            <a:ext cx="4990084" cy="2554448"/>
-          </a:xfrm>
-          <a:prstGeom prst="rect">
-            <a:avLst/>
-          </a:prstGeom>
-        </p:spPr>
-      </p:pic>
-    </p:spTree>
-    <p:extLst>
-      <p:ext uri="{BB962C8B-B14F-4D97-AF65-F5344CB8AC3E}">
-        <p14:creationId xmlns:p14="http://schemas.microsoft.com/office/powerpoint/2010/main" val="348103399"/>
-      </p:ext>
-    </p:extLst>
-  </p:cSld>
-  <p:clrMapOvr>
-    <a:masterClrMapping/>
-  </p:clrMapOvr>
-  <p:timing>
-    <p:tnLst>
-      <p:par>
-        <p:cTn id="1" dur="indefinite" restart="never" nodeType="tmRoot"/>
-      </p:par>
-    </p:tnLst>
-  </p:timing>
-</p:sld>
-</file>
-
-<file path=ppt/slides/slide25.xml><?xml version="1.0" encoding="utf-8"?>
-<p:sld xmlns:a="http://schemas.openxmlformats.org/drawingml/2006/main" xmlns:r="http://schemas.openxmlformats.org/officeDocument/2006/relationships" xmlns:p="http://schemas.openxmlformats.org/presentationml/2006/main">
-  <p:cSld>
-    <p:spTree>
-      <p:nvGrpSpPr>
-        <p:cNvPr id="1" name=""/>
-        <p:cNvGrpSpPr/>
-        <p:nvPr/>
-      </p:nvGrpSpPr>
-      <p:grpSpPr>
-        <a:xfrm>
-          <a:off x="0" y="0"/>
-          <a:ext cx="0" cy="0"/>
-          <a:chOff x="0" y="0"/>
-          <a:chExt cx="0" cy="0"/>
-        </a:xfrm>
-      </p:grpSpPr>
-      <p:sp>
-        <p:nvSpPr>
-          <p:cNvPr id="2" name="Title 1">
-            <a:extLst>
-              <a:ext uri="{FF2B5EF4-FFF2-40B4-BE49-F238E27FC236}">
-                <a16:creationId xmlns:a16="http://schemas.microsoft.com/office/drawing/2014/main" id="{954ABE40-AA00-F366-A36A-B3F1AADBF025}"/>
-              </a:ext>
-            </a:extLst>
-          </p:cNvPr>
-          <p:cNvSpPr>
-            <a:spLocks noGrp="1"/>
-          </p:cNvSpPr>
-          <p:nvPr>
-            <p:ph type="ctrTitle"/>
-          </p:nvPr>
-        </p:nvSpPr>
-        <p:spPr>
-          <a:xfrm>
-            <a:off x="550862" y="196900"/>
-            <a:ext cx="11057663" cy="604289"/>
-          </a:xfrm>
-          <a:noFill/>
-        </p:spPr>
-        <p:txBody>
-          <a:bodyPr>
-            <a:noAutofit/>
-          </a:bodyPr>
-          <a:lstStyle/>
-          <a:p>
-            <a:r>
-              <a:rPr lang="en-US" dirty="0" smtClean="0">
-                <a:latin typeface="+mn-lt"/>
-              </a:rPr>
-              <a:t>Execution of the Code</a:t>
-            </a:r>
-            <a:endParaRPr lang="en-US" dirty="0">
-              <a:latin typeface="+mn-lt"/>
-            </a:endParaRPr>
-          </a:p>
-        </p:txBody>
-      </p:sp>
-      <p:pic>
-        <p:nvPicPr>
-          <p:cNvPr id="3" name="Picture 2"/>
-          <p:cNvPicPr>
-            <a:picLocks noChangeAspect="1"/>
-          </p:cNvPicPr>
-          <p:nvPr/>
-        </p:nvPicPr>
-        <p:blipFill>
-          <a:blip r:embed="rId3"/>
-          <a:stretch>
-            <a:fillRect/>
-          </a:stretch>
-        </p:blipFill>
-        <p:spPr>
-          <a:xfrm>
-            <a:off x="2500173" y="981347"/>
-            <a:ext cx="7820892" cy="5560166"/>
-          </a:xfrm>
-          <a:prstGeom prst="rect">
-            <a:avLst/>
-          </a:prstGeom>
-        </p:spPr>
-      </p:pic>
-    </p:spTree>
-    <p:extLst>
-      <p:ext uri="{BB962C8B-B14F-4D97-AF65-F5344CB8AC3E}">
-        <p14:creationId xmlns:p14="http://schemas.microsoft.com/office/powerpoint/2010/main" val="2843615959"/>
-      </p:ext>
-    </p:extLst>
-  </p:cSld>
-  <p:clrMapOvr>
-    <a:masterClrMapping/>
-  </p:clrMapOvr>
-  <p:timing>
-    <p:tnLst>
-      <p:par>
-        <p:cTn id="1" dur="indefinite" restart="never" nodeType="tmRoot"/>
-      </p:par>
-    </p:tnLst>
-  </p:timing>
-</p:sld>
-</file>
-
-<file path=ppt/slides/slide26.xml><?xml version="1.0" encoding="utf-8"?>
-<p:sld xmlns:a="http://schemas.openxmlformats.org/drawingml/2006/main" xmlns:r="http://schemas.openxmlformats.org/officeDocument/2006/relationships" xmlns:p="http://schemas.openxmlformats.org/presentationml/2006/main">
-  <p:cSld>
-    <p:spTree>
-      <p:nvGrpSpPr>
-        <p:cNvPr id="1" name=""/>
-        <p:cNvGrpSpPr/>
-        <p:nvPr/>
-      </p:nvGrpSpPr>
-      <p:grpSpPr>
-        <a:xfrm>
-          <a:off x="0" y="0"/>
-          <a:ext cx="0" cy="0"/>
-          <a:chOff x="0" y="0"/>
-          <a:chExt cx="0" cy="0"/>
-        </a:xfrm>
-      </p:grpSpPr>
-      <p:sp>
-        <p:nvSpPr>
-          <p:cNvPr id="2" name="Title 1">
-            <a:extLst>
-              <a:ext uri="{FF2B5EF4-FFF2-40B4-BE49-F238E27FC236}">
-                <a16:creationId xmlns:a16="http://schemas.microsoft.com/office/drawing/2014/main" id="{954ABE40-AA00-F366-A36A-B3F1AADBF025}"/>
-              </a:ext>
-            </a:extLst>
-          </p:cNvPr>
-          <p:cNvSpPr>
-            <a:spLocks noGrp="1"/>
-          </p:cNvSpPr>
-          <p:nvPr>
-            <p:ph type="ctrTitle"/>
-          </p:nvPr>
-        </p:nvSpPr>
-        <p:spPr>
-          <a:xfrm>
-            <a:off x="550862" y="196900"/>
-            <a:ext cx="11057663" cy="604289"/>
-          </a:xfrm>
-          <a:noFill/>
-        </p:spPr>
-        <p:txBody>
-          <a:bodyPr>
-            <a:noAutofit/>
-          </a:bodyPr>
-          <a:lstStyle/>
-          <a:p>
-            <a:r>
-              <a:rPr lang="en-US" dirty="0" smtClean="0">
-                <a:latin typeface="+mn-lt"/>
-              </a:rPr>
-              <a:t>Execution of the Code</a:t>
-            </a:r>
-            <a:endParaRPr lang="en-US" dirty="0">
-              <a:latin typeface="+mn-lt"/>
-            </a:endParaRPr>
-          </a:p>
-        </p:txBody>
-      </p:sp>
-      <p:pic>
-        <p:nvPicPr>
-          <p:cNvPr id="4" name="Picture 3"/>
-          <p:cNvPicPr>
-            <a:picLocks noChangeAspect="1"/>
-          </p:cNvPicPr>
-          <p:nvPr/>
-        </p:nvPicPr>
-        <p:blipFill>
-          <a:blip r:embed="rId3"/>
-          <a:stretch>
-            <a:fillRect/>
-          </a:stretch>
-        </p:blipFill>
-        <p:spPr>
-          <a:xfrm>
-            <a:off x="2186367" y="927156"/>
-            <a:ext cx="8020080" cy="5719678"/>
-          </a:xfrm>
-          <a:prstGeom prst="rect">
-            <a:avLst/>
-          </a:prstGeom>
-        </p:spPr>
-      </p:pic>
-    </p:spTree>
-    <p:extLst>
-      <p:ext uri="{BB962C8B-B14F-4D97-AF65-F5344CB8AC3E}">
-        <p14:creationId xmlns:p14="http://schemas.microsoft.com/office/powerpoint/2010/main" val="2437784817"/>
-      </p:ext>
-    </p:extLst>
-  </p:cSld>
-  <p:clrMapOvr>
-    <a:masterClrMapping/>
-  </p:clrMapOvr>
-  <p:timing>
-    <p:tnLst>
-      <p:par>
-        <p:cTn id="1" dur="indefinite" restart="never" nodeType="tmRoot"/>
-      </p:par>
-    </p:tnLst>
-  </p:timing>
-</p:sld>
-</file>
-
-<file path=ppt/slides/slide27.xml><?xml version="1.0" encoding="utf-8"?>
-<p:sld xmlns:a="http://schemas.openxmlformats.org/drawingml/2006/main" xmlns:r="http://schemas.openxmlformats.org/officeDocument/2006/relationships" xmlns:p="http://schemas.openxmlformats.org/presentationml/2006/main">
-  <p:cSld>
-    <p:spTree>
-      <p:nvGrpSpPr>
-        <p:cNvPr id="1" name=""/>
-        <p:cNvGrpSpPr/>
-        <p:nvPr/>
-      </p:nvGrpSpPr>
-      <p:grpSpPr>
-        <a:xfrm>
-          <a:off x="0" y="0"/>
-          <a:ext cx="0" cy="0"/>
-          <a:chOff x="0" y="0"/>
-          <a:chExt cx="0" cy="0"/>
-        </a:xfrm>
-      </p:grpSpPr>
-      <p:sp>
-        <p:nvSpPr>
-          <p:cNvPr id="2" name="Title 1">
-            <a:extLst>
-              <a:ext uri="{FF2B5EF4-FFF2-40B4-BE49-F238E27FC236}">
-                <a16:creationId xmlns:a16="http://schemas.microsoft.com/office/drawing/2014/main" id="{954ABE40-AA00-F366-A36A-B3F1AADBF025}"/>
-              </a:ext>
-            </a:extLst>
-          </p:cNvPr>
-          <p:cNvSpPr>
-            <a:spLocks noGrp="1"/>
-          </p:cNvSpPr>
-          <p:nvPr>
-            <p:ph type="ctrTitle"/>
-          </p:nvPr>
-        </p:nvSpPr>
-        <p:spPr>
-          <a:xfrm>
-            <a:off x="550862" y="196900"/>
-            <a:ext cx="11057663" cy="604289"/>
-          </a:xfrm>
-          <a:noFill/>
-        </p:spPr>
-        <p:txBody>
-          <a:bodyPr>
-            <a:noAutofit/>
-          </a:bodyPr>
-          <a:lstStyle/>
-          <a:p>
-            <a:r>
-              <a:rPr lang="en-US" dirty="0" smtClean="0">
-                <a:latin typeface="+mn-lt"/>
-              </a:rPr>
-              <a:t>Execution of the Code</a:t>
-            </a:r>
-            <a:endParaRPr lang="en-US" dirty="0">
-              <a:latin typeface="+mn-lt"/>
-            </a:endParaRPr>
-          </a:p>
-        </p:txBody>
-      </p:sp>
-      <p:pic>
-        <p:nvPicPr>
-          <p:cNvPr id="3" name="Picture 2"/>
-          <p:cNvPicPr>
-            <a:picLocks noChangeAspect="1"/>
-          </p:cNvPicPr>
-          <p:nvPr/>
-        </p:nvPicPr>
-        <p:blipFill>
-          <a:blip r:embed="rId3"/>
-          <a:stretch>
-            <a:fillRect/>
-          </a:stretch>
-        </p:blipFill>
-        <p:spPr>
-          <a:xfrm>
-            <a:off x="2345955" y="1029600"/>
-            <a:ext cx="7668902" cy="5437482"/>
-          </a:xfrm>
-          <a:prstGeom prst="rect">
-            <a:avLst/>
-          </a:prstGeom>
-        </p:spPr>
-      </p:pic>
-      <p:sp>
-        <p:nvSpPr>
-          <p:cNvPr id="5" name="Oval 4"/>
-          <p:cNvSpPr/>
-          <p:nvPr/>
-        </p:nvSpPr>
-        <p:spPr>
-          <a:xfrm>
-            <a:off x="7872549" y="1288869"/>
-            <a:ext cx="2142308" cy="635725"/>
-          </a:xfrm>
-          <a:prstGeom prst="ellipse">
-            <a:avLst/>
-          </a:prstGeom>
-          <a:noFill/>
-          <a:ln>
-            <a:solidFill>
-              <a:srgbClr val="C00000"/>
-            </a:solidFill>
-          </a:ln>
-        </p:spPr>
-        <p:style>
-          <a:lnRef idx="2">
-            <a:schemeClr val="accent1">
-              <a:shade val="50000"/>
-            </a:schemeClr>
-          </a:lnRef>
-          <a:fillRef idx="1">
-            <a:schemeClr val="accent1"/>
-          </a:fillRef>
-          <a:effectRef idx="0">
-            <a:schemeClr val="accent1"/>
-          </a:effectRef>
-          <a:fontRef idx="minor">
-            <a:schemeClr val="lt1"/>
-          </a:fontRef>
-        </p:style>
-        <p:txBody>
-          <a:bodyPr rtlCol="0" anchor="ctr"/>
-          <a:lstStyle/>
-          <a:p>
-            <a:pPr algn="ctr"/>
-            <a:endParaRPr lang="en-IN"/>
-          </a:p>
-        </p:txBody>
-      </p:sp>
-      <p:cxnSp>
-        <p:nvCxnSpPr>
-          <p:cNvPr id="9" name="Straight Arrow Connector 8"/>
-          <p:cNvCxnSpPr>
-            <a:endCxn id="5" idx="4"/>
-          </p:cNvCxnSpPr>
-          <p:nvPr/>
-        </p:nvCxnSpPr>
-        <p:spPr>
-          <a:xfrm flipV="1">
-            <a:off x="8786949" y="1924594"/>
-            <a:ext cx="156754" cy="4127863"/>
-          </a:xfrm>
-          <a:prstGeom prst="straightConnector1">
-            <a:avLst/>
-          </a:prstGeom>
-          <a:ln>
-            <a:solidFill>
-              <a:srgbClr val="FF0000"/>
-            </a:solidFill>
-            <a:tailEnd type="triangle"/>
-          </a:ln>
-        </p:spPr>
-        <p:style>
-          <a:lnRef idx="1">
-            <a:schemeClr val="accent3"/>
-          </a:lnRef>
-          <a:fillRef idx="0">
-            <a:schemeClr val="accent3"/>
-          </a:fillRef>
-          <a:effectRef idx="0">
-            <a:schemeClr val="accent3"/>
-          </a:effectRef>
-          <a:fontRef idx="minor">
-            <a:schemeClr val="tx1"/>
-          </a:fontRef>
-        </p:style>
-      </p:cxnSp>
-    </p:spTree>
-    <p:extLst>
-      <p:ext uri="{BB962C8B-B14F-4D97-AF65-F5344CB8AC3E}">
-        <p14:creationId xmlns:p14="http://schemas.microsoft.com/office/powerpoint/2010/main" val="3805885701"/>
-      </p:ext>
-    </p:extLst>
-  </p:cSld>
-  <p:clrMapOvr>
-    <a:masterClrMapping/>
-  </p:clrMapOvr>
-  <p:timing>
-    <p:tnLst>
-      <p:par>
-        <p:cTn id="1" dur="indefinite" restart="never" nodeType="tmRoot"/>
-      </p:par>
-    </p:tnLst>
-  </p:timing>
-</p:sld>
-</file>
-
-<file path=ppt/slides/slide28.xml><?xml version="1.0" encoding="utf-8"?>
-<p:sld xmlns:a="http://schemas.openxmlformats.org/drawingml/2006/main" xmlns:r="http://schemas.openxmlformats.org/officeDocument/2006/relationships" xmlns:p="http://schemas.openxmlformats.org/presentationml/2006/main">
-  <p:cSld>
-    <p:spTree>
-      <p:nvGrpSpPr>
-        <p:cNvPr id="1" name=""/>
-        <p:cNvGrpSpPr/>
-        <p:nvPr/>
-      </p:nvGrpSpPr>
-      <p:grpSpPr>
-        <a:xfrm>
-          <a:off x="0" y="0"/>
-          <a:ext cx="0" cy="0"/>
-          <a:chOff x="0" y="0"/>
-          <a:chExt cx="0" cy="0"/>
-        </a:xfrm>
-      </p:grpSpPr>
-      <p:sp>
-        <p:nvSpPr>
-          <p:cNvPr id="2" name="Title 1">
-            <a:extLst>
-              <a:ext uri="{FF2B5EF4-FFF2-40B4-BE49-F238E27FC236}">
-                <a16:creationId xmlns:a16="http://schemas.microsoft.com/office/drawing/2014/main" id="{954ABE40-AA00-F366-A36A-B3F1AADBF025}"/>
-              </a:ext>
-            </a:extLst>
-          </p:cNvPr>
-          <p:cNvSpPr>
-            <a:spLocks noGrp="1"/>
-          </p:cNvSpPr>
-          <p:nvPr>
-            <p:ph type="ctrTitle"/>
-          </p:nvPr>
-        </p:nvSpPr>
-        <p:spPr>
-          <a:xfrm>
-            <a:off x="550862" y="196900"/>
-            <a:ext cx="11057663" cy="604289"/>
-          </a:xfrm>
-          <a:noFill/>
-        </p:spPr>
-        <p:txBody>
-          <a:bodyPr>
-            <a:noAutofit/>
-          </a:bodyPr>
-          <a:lstStyle/>
-          <a:p>
-            <a:r>
-              <a:rPr lang="en-US" dirty="0" smtClean="0">
-                <a:latin typeface="+mn-lt"/>
-              </a:rPr>
-              <a:t>Execution of the Code</a:t>
-            </a:r>
-            <a:endParaRPr lang="en-US" dirty="0">
-              <a:latin typeface="+mn-lt"/>
-            </a:endParaRPr>
-          </a:p>
-        </p:txBody>
-      </p:sp>
-      <p:pic>
-        <p:nvPicPr>
-          <p:cNvPr id="4" name="Picture 3"/>
-          <p:cNvPicPr>
-            <a:picLocks noChangeAspect="1"/>
-          </p:cNvPicPr>
-          <p:nvPr/>
-        </p:nvPicPr>
-        <p:blipFill>
-          <a:blip r:embed="rId3"/>
-          <a:stretch>
-            <a:fillRect/>
-          </a:stretch>
-        </p:blipFill>
-        <p:spPr>
-          <a:xfrm>
-            <a:off x="3503748" y="1907177"/>
-            <a:ext cx="5628041" cy="3021874"/>
-          </a:xfrm>
-          <a:prstGeom prst="rect">
-            <a:avLst/>
-          </a:prstGeom>
-        </p:spPr>
-      </p:pic>
-    </p:spTree>
-    <p:extLst>
-      <p:ext uri="{BB962C8B-B14F-4D97-AF65-F5344CB8AC3E}">
-        <p14:creationId xmlns:p14="http://schemas.microsoft.com/office/powerpoint/2010/main" val="684170328"/>
+        <p14:creationId xmlns:p14="http://schemas.microsoft.com/office/powerpoint/2010/main" val="2216361744"/>
       </p:ext>
     </p:extLst>
   </p:cSld>
@@ -15987,13 +14877,7 @@
               <a:rPr lang="en-US" dirty="0" smtClean="0">
                 <a:latin typeface="+mn-lt"/>
               </a:rPr>
-              <a:t>Dataset </a:t>
-            </a:r>
-            <a:r>
-              <a:rPr lang="en-US" dirty="0" smtClean="0">
-                <a:latin typeface="+mn-lt"/>
-              </a:rPr>
-              <a:t>Sample (Sleep Efficiency)</a:t>
+              <a:t>Dataset Sample (Sleep Efficiency)</a:t>
             </a:r>
             <a:endParaRPr lang="en-US" dirty="0">
               <a:latin typeface="+mn-lt"/>
@@ -19173,13 +18057,7 @@
               <a:rPr lang="en-US" dirty="0" smtClean="0">
                 <a:latin typeface="+mn-lt"/>
               </a:rPr>
-              <a:t>Code: </a:t>
-            </a:r>
-            <a:r>
-              <a:rPr lang="en-US" dirty="0" smtClean="0">
-                <a:latin typeface="+mn-lt"/>
-              </a:rPr>
-              <a:t>Sleep Analysis Model (Overview)</a:t>
+              <a:t>Code: Sleep Analysis Model (Overview)</a:t>
             </a:r>
             <a:endParaRPr lang="en-US" dirty="0">
               <a:latin typeface="+mn-lt"/>
@@ -19465,13 +18343,7 @@
               <a:rPr lang="en-US" dirty="0" smtClean="0">
                 <a:latin typeface="+mn-lt"/>
               </a:rPr>
-              <a:t>Finding Outliers: </a:t>
-            </a:r>
-            <a:r>
-              <a:rPr lang="en-US" dirty="0" smtClean="0">
-                <a:latin typeface="+mn-lt"/>
-              </a:rPr>
-              <a:t>Sleep Analysis Model (Overview)</a:t>
+              <a:t>Finding Outliers: Sleep Analysis Model (Overview)</a:t>
             </a:r>
             <a:endParaRPr lang="en-US" dirty="0">
               <a:latin typeface="+mn-lt"/>
@@ -19753,13 +18625,7 @@
               <a:rPr lang="en-US" dirty="0" smtClean="0">
                 <a:latin typeface="+mn-lt"/>
               </a:rPr>
-              <a:t>Finding Outliers: </a:t>
-            </a:r>
-            <a:r>
-              <a:rPr lang="en-US" dirty="0" smtClean="0">
-                <a:latin typeface="+mn-lt"/>
-              </a:rPr>
-              <a:t>Sleep Analysis Model (Overview)</a:t>
+              <a:t>Finding Outliers: Sleep Analysis Model (Overview)</a:t>
             </a:r>
             <a:endParaRPr lang="en-US" dirty="0">
               <a:latin typeface="+mn-lt"/>
@@ -20029,13 +18895,7 @@
               <a:rPr lang="en-US" dirty="0" smtClean="0">
                 <a:latin typeface="+mn-lt"/>
               </a:rPr>
-              <a:t>Data Cleaning</a:t>
-            </a:r>
-            <a:r>
-              <a:rPr lang="en-US" dirty="0" smtClean="0">
-                <a:latin typeface="+mn-lt"/>
-              </a:rPr>
-              <a:t>: Handling the missing Values</a:t>
+              <a:t>Data Cleaning: Handling the missing Values</a:t>
             </a:r>
             <a:endParaRPr lang="en-US" dirty="0">
               <a:latin typeface="+mn-lt"/>
@@ -20305,13 +19165,7 @@
               <a:rPr lang="en-US" dirty="0" smtClean="0">
                 <a:latin typeface="+mn-lt"/>
               </a:rPr>
-              <a:t>Feature Engineering</a:t>
-            </a:r>
-            <a:r>
-              <a:rPr lang="en-US" dirty="0" smtClean="0">
-                <a:latin typeface="+mn-lt"/>
-              </a:rPr>
-              <a:t>: </a:t>
+              <a:t>Feature Engineering: </a:t>
             </a:r>
             <a:r>
               <a:rPr lang="en-US" dirty="0" err="1" smtClean="0">
@@ -21337,6 +20191,26 @@
 </file>
 
 <file path=customXml/item1.xml><?xml version="1.0" encoding="utf-8"?>
+<p:properties xmlns:p="http://schemas.microsoft.com/office/2006/metadata/properties" xmlns:xsi="http://www.w3.org/2001/XMLSchema-instance" xmlns:pc="http://schemas.microsoft.com/office/infopath/2007/PartnerControls">
+  <documentManagement>
+    <_ip_UnifiedCompliancePolicyUIAction xmlns="http://schemas.microsoft.com/sharepoint/v3" xsi:nil="true"/>
+    <Image xmlns="71af3243-3dd4-4a8d-8c0d-dd76da1f02a5">
+      <Url xsi:nil="true"/>
+      <Description xsi:nil="true"/>
+    </Image>
+    <Status xmlns="71af3243-3dd4-4a8d-8c0d-dd76da1f02a5">Not started</Status>
+    <Background xmlns="71af3243-3dd4-4a8d-8c0d-dd76da1f02a5">false</Background>
+    <_ip_UnifiedCompliancePolicyProperties xmlns="http://schemas.microsoft.com/sharepoint/v3" xsi:nil="true"/>
+    <ImageTagsTaxHTField xmlns="71af3243-3dd4-4a8d-8c0d-dd76da1f02a5">
+      <Terms xmlns="http://schemas.microsoft.com/office/infopath/2007/PartnerControls"/>
+    </ImageTagsTaxHTField>
+    <TaxCatchAll xmlns="230e9df3-be65-4c73-a93b-d1236ebd677e" xsi:nil="true"/>
+    <MediaServiceKeyPoints xmlns="71af3243-3dd4-4a8d-8c0d-dd76da1f02a5" xsi:nil="true"/>
+  </documentManagement>
+</p:properties>
+</file>
+
+<file path=customXml/item2.xml><?xml version="1.0" encoding="utf-8"?>
 <ct:contentTypeSchema xmlns:ct="http://schemas.microsoft.com/office/2006/metadata/contentType" xmlns:ma="http://schemas.microsoft.com/office/2006/metadata/properties/metaAttributes" ct:_="" ma:_="" ma:contentTypeName="Document" ma:contentTypeID="0x01010079F111ED35F8CC479449609E8A0923A6" ma:contentTypeVersion="28" ma:contentTypeDescription="Create a new document." ma:contentTypeScope="" ma:versionID="60f5a4f2d2b0abadcf532d48ebf9cb71">
   <xsd:schema xmlns:xsd="http://www.w3.org/2001/XMLSchema" xmlns:xs="http://www.w3.org/2001/XMLSchema" xmlns:p="http://schemas.microsoft.com/office/2006/metadata/properties" xmlns:ns1="http://schemas.microsoft.com/sharepoint/v3" xmlns:ns2="71af3243-3dd4-4a8d-8c0d-dd76da1f02a5" xmlns:ns3="16c05727-aa75-4e4a-9b5f-8a80a1165891" xmlns:ns4="230e9df3-be65-4c73-a93b-d1236ebd677e" targetNamespace="http://schemas.microsoft.com/office/2006/metadata/properties" ma:root="true" ma:fieldsID="7dd78129e6a1811f84807ad11c651531" ns1:_="" ns2:_="" ns3:_="" ns4:_="">
     <xsd:import namespace="http://schemas.microsoft.com/sharepoint/v3"/>
@@ -21648,26 +20522,6 @@
 </ct:contentTypeSchema>
 </file>
 
-<file path=customXml/item2.xml><?xml version="1.0" encoding="utf-8"?>
-<p:properties xmlns:p="http://schemas.microsoft.com/office/2006/metadata/properties" xmlns:xsi="http://www.w3.org/2001/XMLSchema-instance" xmlns:pc="http://schemas.microsoft.com/office/infopath/2007/PartnerControls">
-  <documentManagement>
-    <_ip_UnifiedCompliancePolicyUIAction xmlns="http://schemas.microsoft.com/sharepoint/v3" xsi:nil="true"/>
-    <Image xmlns="71af3243-3dd4-4a8d-8c0d-dd76da1f02a5">
-      <Url xsi:nil="true"/>
-      <Description xsi:nil="true"/>
-    </Image>
-    <Status xmlns="71af3243-3dd4-4a8d-8c0d-dd76da1f02a5">Not started</Status>
-    <Background xmlns="71af3243-3dd4-4a8d-8c0d-dd76da1f02a5">false</Background>
-    <_ip_UnifiedCompliancePolicyProperties xmlns="http://schemas.microsoft.com/sharepoint/v3" xsi:nil="true"/>
-    <ImageTagsTaxHTField xmlns="71af3243-3dd4-4a8d-8c0d-dd76da1f02a5">
-      <Terms xmlns="http://schemas.microsoft.com/office/infopath/2007/PartnerControls"/>
-    </ImageTagsTaxHTField>
-    <TaxCatchAll xmlns="230e9df3-be65-4c73-a93b-d1236ebd677e" xsi:nil="true"/>
-    <MediaServiceKeyPoints xmlns="71af3243-3dd4-4a8d-8c0d-dd76da1f02a5" xsi:nil="true"/>
-  </documentManagement>
-</p:properties>
-</file>
-
 <file path=customXml/item3.xml><?xml version="1.0" encoding="utf-8"?>
 <?mso-contentType ?>
 <FormTemplates xmlns="http://schemas.microsoft.com/sharepoint/v3/contenttype/forms">
@@ -21678,6 +20532,25 @@
 </file>
 
 <file path=customXml/itemProps1.xml><?xml version="1.0" encoding="utf-8"?>
+<ds:datastoreItem xmlns:ds="http://schemas.openxmlformats.org/officeDocument/2006/customXml" ds:itemID="{1F342EE1-43E5-4AFB-895D-B61B9656DC14}">
+  <ds:schemaRefs>
+    <ds:schemaRef ds:uri="http://schemas.microsoft.com/office/2006/documentManagement/types"/>
+    <ds:schemaRef ds:uri="http://schemas.microsoft.com/sharepoint/v3"/>
+    <ds:schemaRef ds:uri="16c05727-aa75-4e4a-9b5f-8a80a1165891"/>
+    <ds:schemaRef ds:uri="230e9df3-be65-4c73-a93b-d1236ebd677e"/>
+    <ds:schemaRef ds:uri="http://schemas.microsoft.com/office/2006/metadata/properties"/>
+    <ds:schemaRef ds:uri="http://purl.org/dc/terms/"/>
+    <ds:schemaRef ds:uri="http://www.w3.org/XML/1998/namespace"/>
+    <ds:schemaRef ds:uri="http://purl.org/dc/dcmitype/"/>
+    <ds:schemaRef ds:uri="http://schemas.openxmlformats.org/package/2006/metadata/core-properties"/>
+    <ds:schemaRef ds:uri="http://schemas.microsoft.com/office/infopath/2007/PartnerControls"/>
+    <ds:schemaRef ds:uri="71af3243-3dd4-4a8d-8c0d-dd76da1f02a5"/>
+    <ds:schemaRef ds:uri="http://purl.org/dc/elements/1.1/"/>
+  </ds:schemaRefs>
+</ds:datastoreItem>
+</file>
+
+<file path=customXml/itemProps2.xml><?xml version="1.0" encoding="utf-8"?>
 <ds:datastoreItem xmlns:ds="http://schemas.openxmlformats.org/officeDocument/2006/customXml" ds:itemID="{797783A8-901D-4F73-81D7-AA6841BEB3D7}">
   <ds:schemaRefs>
     <ds:schemaRef ds:uri="http://schemas.microsoft.com/office/2006/metadata/contentType"/>
@@ -21698,25 +20571,6 @@
 </ds:datastoreItem>
 </file>
 
-<file path=customXml/itemProps2.xml><?xml version="1.0" encoding="utf-8"?>
-<ds:datastoreItem xmlns:ds="http://schemas.openxmlformats.org/officeDocument/2006/customXml" ds:itemID="{1F342EE1-43E5-4AFB-895D-B61B9656DC14}">
-  <ds:schemaRefs>
-    <ds:schemaRef ds:uri="http://schemas.microsoft.com/office/2006/documentManagement/types"/>
-    <ds:schemaRef ds:uri="http://schemas.microsoft.com/sharepoint/v3"/>
-    <ds:schemaRef ds:uri="16c05727-aa75-4e4a-9b5f-8a80a1165891"/>
-    <ds:schemaRef ds:uri="230e9df3-be65-4c73-a93b-d1236ebd677e"/>
-    <ds:schemaRef ds:uri="http://schemas.microsoft.com/office/2006/metadata/properties"/>
-    <ds:schemaRef ds:uri="http://purl.org/dc/terms/"/>
-    <ds:schemaRef ds:uri="http://www.w3.org/XML/1998/namespace"/>
-    <ds:schemaRef ds:uri="http://purl.org/dc/dcmitype/"/>
-    <ds:schemaRef ds:uri="http://schemas.openxmlformats.org/package/2006/metadata/core-properties"/>
-    <ds:schemaRef ds:uri="http://schemas.microsoft.com/office/infopath/2007/PartnerControls"/>
-    <ds:schemaRef ds:uri="71af3243-3dd4-4a8d-8c0d-dd76da1f02a5"/>
-    <ds:schemaRef ds:uri="http://purl.org/dc/elements/1.1/"/>
-  </ds:schemaRefs>
-</ds:datastoreItem>
-</file>
-
 <file path=customXml/itemProps3.xml><?xml version="1.0" encoding="utf-8"?>
 <ds:datastoreItem xmlns:ds="http://schemas.openxmlformats.org/officeDocument/2006/customXml" ds:itemID="{2F49CD38-5B57-4682-9FCE-B9174068D0AE}">
   <ds:schemaRefs>

</xml_diff>